<commit_message>
Update PowerPoint for song #162 in FUBC - Українські
</commit_message>
<xml_diff>
--- a/fubc-ua/162-Небесний спокій я знайшов (Пісні Спасенних №160).pptx
+++ b/fubc-ua/162-Небесний спокій я знайшов (Пісні Спасенних №160).pptx
@@ -1943,7 +1943,7 @@
         </p:nvSpPr>
         <p:spPr>
           <a:xfrm>
-            <a:off x="3317443" y="2359152"/>
+            <a:off x="3416503" y="2359152"/>
             <a:ext cx="0" cy="594360"/>
           </a:xfrm>
           <a:prstGeom prst="line">
@@ -1966,7 +1966,7 @@
         </p:nvSpPr>
         <p:spPr>
           <a:xfrm>
-            <a:off x="8880653" y="2359152"/>
+            <a:off x="8781593" y="2359152"/>
             <a:ext cx="0" cy="594360"/>
           </a:xfrm>
           <a:prstGeom prst="line">
@@ -1989,8 +1989,8 @@
         </p:nvSpPr>
         <p:spPr>
           <a:xfrm>
-            <a:off x="9012733" y="2425192"/>
-            <a:ext cx="792480" cy="462280"/>
+            <a:off x="8880653" y="2336292"/>
+            <a:ext cx="1097280" cy="640080"/>
           </a:xfrm>
           <a:prstGeom prst="rect">
             <a:avLst/>
@@ -2006,9 +2006,9 @@
               <a:buNone/>
             </a:pPr>
             <a:r>
-              <a:rPr lang="en-US" sz="2600" b="1" dirty="0">
-                <a:solidFill>
-                  <a:srgbClr val="8A8A8A"/>
+              <a:rPr lang="en-US" sz="3600" b="1" dirty="0">
+                <a:solidFill>
+                  <a:srgbClr val="BBBBBB"/>
                 </a:solidFill>
                 <a:latin typeface="Arial" pitchFamily="34" charset="0"/>
                 <a:ea typeface="Arial" pitchFamily="34" charset="-122"/>
@@ -2016,7 +2016,7 @@
               </a:rPr>
               <a:t>×2</a:t>
             </a:r>
-            <a:endParaRPr lang="en-US" sz="2600" dirty="0"/>
+            <a:endParaRPr lang="en-US" sz="3600" dirty="0"/>
           </a:p>
         </p:txBody>
       </p:sp>
@@ -2535,7 +2535,7 @@
         </p:nvSpPr>
         <p:spPr>
           <a:xfrm>
-            <a:off x="2895448" y="2359152"/>
+            <a:off x="2994508" y="2359152"/>
             <a:ext cx="0" cy="594360"/>
           </a:xfrm>
           <a:prstGeom prst="line">
@@ -2558,7 +2558,7 @@
         </p:nvSpPr>
         <p:spPr>
           <a:xfrm>
-            <a:off x="9302648" y="2359152"/>
+            <a:off x="9203588" y="2359152"/>
             <a:ext cx="0" cy="594360"/>
           </a:xfrm>
           <a:prstGeom prst="line">
@@ -2581,8 +2581,8 @@
         </p:nvSpPr>
         <p:spPr>
           <a:xfrm>
-            <a:off x="9434728" y="2425192"/>
-            <a:ext cx="792480" cy="462280"/>
+            <a:off x="9302648" y="2336292"/>
+            <a:ext cx="1097280" cy="640080"/>
           </a:xfrm>
           <a:prstGeom prst="rect">
             <a:avLst/>
@@ -2598,9 +2598,9 @@
               <a:buNone/>
             </a:pPr>
             <a:r>
-              <a:rPr lang="en-US" sz="2600" b="1" dirty="0">
-                <a:solidFill>
-                  <a:srgbClr val="8A8A8A"/>
+              <a:rPr lang="en-US" sz="3600" b="1" dirty="0">
+                <a:solidFill>
+                  <a:srgbClr val="BBBBBB"/>
                 </a:solidFill>
                 <a:latin typeface="Arial" pitchFamily="34" charset="0"/>
                 <a:ea typeface="Arial" pitchFamily="34" charset="-122"/>
@@ -2608,7 +2608,7 @@
               </a:rPr>
               <a:t>×2</a:t>
             </a:r>
-            <a:endParaRPr lang="en-US" sz="2600" dirty="0"/>
+            <a:endParaRPr lang="en-US" sz="3600" dirty="0"/>
           </a:p>
         </p:txBody>
       </p:sp>
@@ -3073,7 +3073,7 @@
         </p:nvSpPr>
         <p:spPr>
           <a:xfrm>
-            <a:off x="2448027" y="2359152"/>
+            <a:off x="2547087" y="2359152"/>
             <a:ext cx="0" cy="594360"/>
           </a:xfrm>
           <a:prstGeom prst="line">
@@ -3096,7 +3096,7 @@
         </p:nvSpPr>
         <p:spPr>
           <a:xfrm>
-            <a:off x="9750069" y="2359152"/>
+            <a:off x="9651009" y="2359152"/>
             <a:ext cx="0" cy="594360"/>
           </a:xfrm>
           <a:prstGeom prst="line">
@@ -3119,8 +3119,8 @@
         </p:nvSpPr>
         <p:spPr>
           <a:xfrm>
-            <a:off x="9882149" y="2425192"/>
-            <a:ext cx="792480" cy="462280"/>
+            <a:off x="9750069" y="2336292"/>
+            <a:ext cx="1097280" cy="640080"/>
           </a:xfrm>
           <a:prstGeom prst="rect">
             <a:avLst/>
@@ -3136,9 +3136,9 @@
               <a:buNone/>
             </a:pPr>
             <a:r>
-              <a:rPr lang="en-US" sz="2600" b="1" dirty="0">
-                <a:solidFill>
-                  <a:srgbClr val="8A8A8A"/>
+              <a:rPr lang="en-US" sz="3600" b="1" dirty="0">
+                <a:solidFill>
+                  <a:srgbClr val="BBBBBB"/>
                 </a:solidFill>
                 <a:latin typeface="Arial" pitchFamily="34" charset="0"/>
                 <a:ea typeface="Arial" pitchFamily="34" charset="-122"/>
@@ -3146,7 +3146,7 @@
               </a:rPr>
               <a:t>×2</a:t>
             </a:r>
-            <a:endParaRPr lang="en-US" sz="2600" dirty="0"/>
+            <a:endParaRPr lang="en-US" sz="3600" dirty="0"/>
           </a:p>
         </p:txBody>
       </p:sp>

</xml_diff>